<commit_message>
paths to science questions
</commit_message>
<xml_diff>
--- a/Workshop-Sessions/Paths-to-Science/Paths-to-Science.pptx
+++ b/Workshop-Sessions/Paths-to-Science/Paths-to-Science.pptx
@@ -4,6 +4,9 @@
   <p:sldMasterIdLst>
     <p:sldMasterId id="2147483648" r:id="rId1"/>
   </p:sldMasterIdLst>
+  <p:notesMasterIdLst>
+    <p:notesMasterId r:id="rId13"/>
+  </p:notesMasterIdLst>
   <p:sldIdLst>
     <p:sldId id="256" r:id="rId2"/>
     <p:sldId id="257" r:id="rId3"/>
@@ -15,6 +18,7 @@
     <p:sldId id="263" r:id="rId9"/>
     <p:sldId id="264" r:id="rId10"/>
     <p:sldId id="265" r:id="rId11"/>
+    <p:sldId id="266" r:id="rId12"/>
   </p:sldIdLst>
   <p:sldSz cx="12192000" cy="6858000"/>
   <p:notesSz cx="6858000" cy="9144000"/>
@@ -113,7 +117,614 @@
       </a:defRPr>
     </a:lvl9pPr>
   </p:defaultTextStyle>
+  <p:extLst>
+    <p:ext uri="{EFAFB233-063F-42B5-8137-9DF3F51BA10A}">
+      <p15:sldGuideLst xmlns:p15="http://schemas.microsoft.com/office/powerpoint/2012/main"/>
+    </p:ext>
+  </p:extLst>
 </p:presentation>
+</file>
+
+<file path=ppt/revisionInfo.xml><?xml version="1.0" encoding="utf-8"?>
+<p1510:revInfo xmlns:a="http://schemas.openxmlformats.org/drawingml/2006/main" xmlns:r="http://schemas.openxmlformats.org/officeDocument/2006/relationships" xmlns:p1510="http://schemas.microsoft.com/office/powerpoint/2015/10/main">
+  <p1510:revLst>
+    <p1510:client id="{076D86FC-FEBA-5B49-8274-15755C1DB991}" v="2" dt="2026-07-28T15:36:23.494"/>
+  </p1510:revLst>
+</p1510:revInfo>
+</file>
+
+<file path=ppt/changesInfos/changesInfo1.xml><?xml version="1.0" encoding="utf-8"?>
+<pc:chgInfo xmlns:a="http://schemas.openxmlformats.org/drawingml/2006/main" xmlns:r="http://schemas.openxmlformats.org/officeDocument/2006/relationships" xmlns:ac="http://schemas.microsoft.com/office/drawing/2013/main/command" xmlns:pc="http://schemas.microsoft.com/office/powerpoint/2013/main/command">
+  <pc:docChgLst>
+    <pc:chgData name="Meg Hemmerlein" userId="675d0259-84a2-4ee2-a6c1-034493f7a163" providerId="ADAL" clId="{012228E1-9350-51F7-B0E8-CFC048A68215}"/>
+    <pc:docChg chg="undo custSel addSld delSld modSld">
+      <pc:chgData name="Meg Hemmerlein" userId="675d0259-84a2-4ee2-a6c1-034493f7a163" providerId="ADAL" clId="{012228E1-9350-51F7-B0E8-CFC048A68215}" dt="2026-07-28T15:42:07.151" v="778" actId="20577"/>
+      <pc:docMkLst>
+        <pc:docMk/>
+      </pc:docMkLst>
+      <pc:sldChg chg="addSp modSp mod">
+        <pc:chgData name="Meg Hemmerlein" userId="675d0259-84a2-4ee2-a6c1-034493f7a163" providerId="ADAL" clId="{012228E1-9350-51F7-B0E8-CFC048A68215}" dt="2026-07-28T15:41:11.946" v="677" actId="1076"/>
+        <pc:sldMkLst>
+          <pc:docMk/>
+          <pc:sldMk cId="2326028647" sldId="258"/>
+        </pc:sldMkLst>
+        <pc:picChg chg="add mod">
+          <ac:chgData name="Meg Hemmerlein" userId="675d0259-84a2-4ee2-a6c1-034493f7a163" providerId="ADAL" clId="{012228E1-9350-51F7-B0E8-CFC048A68215}" dt="2026-07-28T15:40:28.339" v="671" actId="1076"/>
+          <ac:picMkLst>
+            <pc:docMk/>
+            <pc:sldMk cId="2326028647" sldId="258"/>
+            <ac:picMk id="3" creationId="{32210182-771B-1B27-11AE-4E4C6D61D283}"/>
+          </ac:picMkLst>
+        </pc:picChg>
+        <pc:picChg chg="mod">
+          <ac:chgData name="Meg Hemmerlein" userId="675d0259-84a2-4ee2-a6c1-034493f7a163" providerId="ADAL" clId="{012228E1-9350-51F7-B0E8-CFC048A68215}" dt="2026-07-28T15:40:24.650" v="670" actId="1076"/>
+          <ac:picMkLst>
+            <pc:docMk/>
+            <pc:sldMk cId="2326028647" sldId="258"/>
+            <ac:picMk id="11" creationId="{6C5CCD9A-B13B-F877-EA07-25E47ED0D47B}"/>
+          </ac:picMkLst>
+        </pc:picChg>
+        <pc:picChg chg="mod modCrop">
+          <ac:chgData name="Meg Hemmerlein" userId="675d0259-84a2-4ee2-a6c1-034493f7a163" providerId="ADAL" clId="{012228E1-9350-51F7-B0E8-CFC048A68215}" dt="2026-07-28T15:41:11.946" v="677" actId="1076"/>
+          <ac:picMkLst>
+            <pc:docMk/>
+            <pc:sldMk cId="2326028647" sldId="258"/>
+            <ac:picMk id="15" creationId="{D31DD2A3-9603-4AB5-E39A-B4AB48E14300}"/>
+          </ac:picMkLst>
+        </pc:picChg>
+      </pc:sldChg>
+      <pc:sldChg chg="addSp modSp mod">
+        <pc:chgData name="Meg Hemmerlein" userId="675d0259-84a2-4ee2-a6c1-034493f7a163" providerId="ADAL" clId="{012228E1-9350-51F7-B0E8-CFC048A68215}" dt="2026-07-28T15:37:12.851" v="148" actId="1076"/>
+        <pc:sldMkLst>
+          <pc:docMk/>
+          <pc:sldMk cId="1294134101" sldId="264"/>
+        </pc:sldMkLst>
+        <pc:spChg chg="mod">
+          <ac:chgData name="Meg Hemmerlein" userId="675d0259-84a2-4ee2-a6c1-034493f7a163" providerId="ADAL" clId="{012228E1-9350-51F7-B0E8-CFC048A68215}" dt="2026-07-28T15:36:20.453" v="4" actId="14100"/>
+          <ac:spMkLst>
+            <pc:docMk/>
+            <pc:sldMk cId="1294134101" sldId="264"/>
+            <ac:spMk id="3" creationId="{588FD44B-7718-4C24-5CE3-9C92362C29DF}"/>
+          </ac:spMkLst>
+        </pc:spChg>
+        <pc:spChg chg="add mod">
+          <ac:chgData name="Meg Hemmerlein" userId="675d0259-84a2-4ee2-a6c1-034493f7a163" providerId="ADAL" clId="{012228E1-9350-51F7-B0E8-CFC048A68215}" dt="2026-07-28T15:37:12.851" v="148" actId="1076"/>
+          <ac:spMkLst>
+            <pc:docMk/>
+            <pc:sldMk cId="1294134101" sldId="264"/>
+            <ac:spMk id="4" creationId="{C7BF5672-E089-CB2B-AD95-9C84D202F4EB}"/>
+          </ac:spMkLst>
+        </pc:spChg>
+        <pc:spChg chg="add mod">
+          <ac:chgData name="Meg Hemmerlein" userId="675d0259-84a2-4ee2-a6c1-034493f7a163" providerId="ADAL" clId="{012228E1-9350-51F7-B0E8-CFC048A68215}" dt="2026-07-28T15:37:12.851" v="148" actId="1076"/>
+          <ac:spMkLst>
+            <pc:docMk/>
+            <pc:sldMk cId="1294134101" sldId="264"/>
+            <ac:spMk id="5" creationId="{1C4CE6D2-6B11-527F-B912-5EB56EBCD5B4}"/>
+          </ac:spMkLst>
+        </pc:spChg>
+      </pc:sldChg>
+      <pc:sldChg chg="del">
+        <pc:chgData name="Meg Hemmerlein" userId="675d0259-84a2-4ee2-a6c1-034493f7a163" providerId="ADAL" clId="{012228E1-9350-51F7-B0E8-CFC048A68215}" dt="2026-07-28T15:36:27.915" v="7" actId="2696"/>
+        <pc:sldMkLst>
+          <pc:docMk/>
+          <pc:sldMk cId="462227079" sldId="265"/>
+        </pc:sldMkLst>
+      </pc:sldChg>
+      <pc:sldChg chg="modSp add mod">
+        <pc:chgData name="Meg Hemmerlein" userId="675d0259-84a2-4ee2-a6c1-034493f7a163" providerId="ADAL" clId="{012228E1-9350-51F7-B0E8-CFC048A68215}" dt="2026-07-28T15:38:35.605" v="441" actId="20577"/>
+        <pc:sldMkLst>
+          <pc:docMk/>
+          <pc:sldMk cId="2292381515" sldId="265"/>
+        </pc:sldMkLst>
+        <pc:spChg chg="mod">
+          <ac:chgData name="Meg Hemmerlein" userId="675d0259-84a2-4ee2-a6c1-034493f7a163" providerId="ADAL" clId="{012228E1-9350-51F7-B0E8-CFC048A68215}" dt="2026-07-28T15:37:22.615" v="168" actId="20577"/>
+          <ac:spMkLst>
+            <pc:docMk/>
+            <pc:sldMk cId="2292381515" sldId="265"/>
+            <ac:spMk id="2" creationId="{654DBA5C-63EE-FE2E-66F8-F5D3804DE497}"/>
+          </ac:spMkLst>
+        </pc:spChg>
+        <pc:spChg chg="mod">
+          <ac:chgData name="Meg Hemmerlein" userId="675d0259-84a2-4ee2-a6c1-034493f7a163" providerId="ADAL" clId="{012228E1-9350-51F7-B0E8-CFC048A68215}" dt="2026-07-28T15:37:56.775" v="305" actId="20577"/>
+          <ac:spMkLst>
+            <pc:docMk/>
+            <pc:sldMk cId="2292381515" sldId="265"/>
+            <ac:spMk id="3" creationId="{E9434E4C-9C1C-5EB8-A236-7C418A41563D}"/>
+          </ac:spMkLst>
+        </pc:spChg>
+        <pc:spChg chg="mod">
+          <ac:chgData name="Meg Hemmerlein" userId="675d0259-84a2-4ee2-a6c1-034493f7a163" providerId="ADAL" clId="{012228E1-9350-51F7-B0E8-CFC048A68215}" dt="2026-07-28T15:38:04.756" v="323" actId="20577"/>
+          <ac:spMkLst>
+            <pc:docMk/>
+            <pc:sldMk cId="2292381515" sldId="265"/>
+            <ac:spMk id="4" creationId="{18FA6F38-DBA6-46A7-4B82-E1A03E456F72}"/>
+          </ac:spMkLst>
+        </pc:spChg>
+        <pc:spChg chg="mod">
+          <ac:chgData name="Meg Hemmerlein" userId="675d0259-84a2-4ee2-a6c1-034493f7a163" providerId="ADAL" clId="{012228E1-9350-51F7-B0E8-CFC048A68215}" dt="2026-07-28T15:38:35.605" v="441" actId="20577"/>
+          <ac:spMkLst>
+            <pc:docMk/>
+            <pc:sldMk cId="2292381515" sldId="265"/>
+            <ac:spMk id="5" creationId="{14E739C5-9421-528C-C2E0-EE33D4E99E48}"/>
+          </ac:spMkLst>
+        </pc:spChg>
+      </pc:sldChg>
+      <pc:sldChg chg="modSp add mod">
+        <pc:chgData name="Meg Hemmerlein" userId="675d0259-84a2-4ee2-a6c1-034493f7a163" providerId="ADAL" clId="{012228E1-9350-51F7-B0E8-CFC048A68215}" dt="2026-07-28T15:42:07.151" v="778" actId="20577"/>
+        <pc:sldMkLst>
+          <pc:docMk/>
+          <pc:sldMk cId="186808384" sldId="266"/>
+        </pc:sldMkLst>
+        <pc:spChg chg="mod">
+          <ac:chgData name="Meg Hemmerlein" userId="675d0259-84a2-4ee2-a6c1-034493f7a163" providerId="ADAL" clId="{012228E1-9350-51F7-B0E8-CFC048A68215}" dt="2026-07-28T15:38:50.817" v="463" actId="20577"/>
+          <ac:spMkLst>
+            <pc:docMk/>
+            <pc:sldMk cId="186808384" sldId="266"/>
+            <ac:spMk id="2" creationId="{514B3BAF-7FAB-F0CC-C0B9-8D121D418F4C}"/>
+          </ac:spMkLst>
+        </pc:spChg>
+        <pc:spChg chg="mod">
+          <ac:chgData name="Meg Hemmerlein" userId="675d0259-84a2-4ee2-a6c1-034493f7a163" providerId="ADAL" clId="{012228E1-9350-51F7-B0E8-CFC048A68215}" dt="2026-07-28T15:39:57.581" v="666" actId="27636"/>
+          <ac:spMkLst>
+            <pc:docMk/>
+            <pc:sldMk cId="186808384" sldId="266"/>
+            <ac:spMk id="3" creationId="{1994A921-34B1-1628-EEDA-7FA957E9FFD2}"/>
+          </ac:spMkLst>
+        </pc:spChg>
+        <pc:spChg chg="mod">
+          <ac:chgData name="Meg Hemmerlein" userId="675d0259-84a2-4ee2-a6c1-034493f7a163" providerId="ADAL" clId="{012228E1-9350-51F7-B0E8-CFC048A68215}" dt="2026-07-28T15:41:44.266" v="697" actId="20577"/>
+          <ac:spMkLst>
+            <pc:docMk/>
+            <pc:sldMk cId="186808384" sldId="266"/>
+            <ac:spMk id="4" creationId="{101ACB80-9F02-10F1-A101-FE05D6095AE2}"/>
+          </ac:spMkLst>
+        </pc:spChg>
+        <pc:spChg chg="mod">
+          <ac:chgData name="Meg Hemmerlein" userId="675d0259-84a2-4ee2-a6c1-034493f7a163" providerId="ADAL" clId="{012228E1-9350-51F7-B0E8-CFC048A68215}" dt="2026-07-28T15:42:07.151" v="778" actId="20577"/>
+          <ac:spMkLst>
+            <pc:docMk/>
+            <pc:sldMk cId="186808384" sldId="266"/>
+            <ac:spMk id="5" creationId="{4EF4ACAA-E279-DF29-A916-D10D6DBD8048}"/>
+          </ac:spMkLst>
+        </pc:spChg>
+      </pc:sldChg>
+    </pc:docChg>
+  </pc:docChgLst>
+</pc:chgInfo>
+</file>
+
+<file path=ppt/notesMasters/notesMaster1.xml><?xml version="1.0" encoding="utf-8"?>
+<p:notesMaster xmlns:a="http://schemas.openxmlformats.org/drawingml/2006/main" xmlns:r="http://schemas.openxmlformats.org/officeDocument/2006/relationships" xmlns:p="http://schemas.openxmlformats.org/presentationml/2006/main">
+  <p:cSld>
+    <p:bg>
+      <p:bgRef idx="1001">
+        <a:schemeClr val="bg1"/>
+      </p:bgRef>
+    </p:bg>
+    <p:spTree>
+      <p:nvGrpSpPr>
+        <p:cNvPr id="1" name=""/>
+        <p:cNvGrpSpPr/>
+        <p:nvPr/>
+      </p:nvGrpSpPr>
+      <p:grpSpPr>
+        <a:xfrm>
+          <a:off x="0" y="0"/>
+          <a:ext cx="0" cy="0"/>
+          <a:chOff x="0" y="0"/>
+          <a:chExt cx="0" cy="0"/>
+        </a:xfrm>
+      </p:grpSpPr>
+      <p:sp>
+        <p:nvSpPr>
+          <p:cNvPr id="2" name="Header Placeholder 1"/>
+          <p:cNvSpPr>
+            <a:spLocks noGrp="1"/>
+          </p:cNvSpPr>
+          <p:nvPr>
+            <p:ph type="hdr" sz="quarter"/>
+          </p:nvPr>
+        </p:nvSpPr>
+        <p:spPr>
+          <a:xfrm>
+            <a:off x="0" y="0"/>
+            <a:ext cx="2971800" cy="458788"/>
+          </a:xfrm>
+          <a:prstGeom prst="rect">
+            <a:avLst/>
+          </a:prstGeom>
+        </p:spPr>
+        <p:txBody>
+          <a:bodyPr vert="horz" lIns="91440" tIns="45720" rIns="91440" bIns="45720" rtlCol="0"/>
+          <a:lstStyle>
+            <a:lvl1pPr algn="l">
+              <a:defRPr sz="1200"/>
+            </a:lvl1pPr>
+          </a:lstStyle>
+          <a:p>
+            <a:endParaRPr lang="en-US"/>
+          </a:p>
+        </p:txBody>
+      </p:sp>
+      <p:sp>
+        <p:nvSpPr>
+          <p:cNvPr id="3" name="Date Placeholder 2"/>
+          <p:cNvSpPr>
+            <a:spLocks noGrp="1"/>
+          </p:cNvSpPr>
+          <p:nvPr>
+            <p:ph type="dt" idx="1"/>
+          </p:nvPr>
+        </p:nvSpPr>
+        <p:spPr>
+          <a:xfrm>
+            <a:off x="3884613" y="0"/>
+            <a:ext cx="2971800" cy="458788"/>
+          </a:xfrm>
+          <a:prstGeom prst="rect">
+            <a:avLst/>
+          </a:prstGeom>
+        </p:spPr>
+        <p:txBody>
+          <a:bodyPr vert="horz" lIns="91440" tIns="45720" rIns="91440" bIns="45720" rtlCol="0"/>
+          <a:lstStyle>
+            <a:lvl1pPr algn="r">
+              <a:defRPr sz="1200"/>
+            </a:lvl1pPr>
+          </a:lstStyle>
+          <a:p>
+            <a:fld id="{E5E7F31A-D2B7-8041-93A0-92F3E8D867AB}" type="datetimeFigureOut">
+              <a:rPr lang="en-US" smtClean="0"/>
+              <a:t>7/28/26</a:t>
+            </a:fld>
+            <a:endParaRPr lang="en-US"/>
+          </a:p>
+        </p:txBody>
+      </p:sp>
+      <p:sp>
+        <p:nvSpPr>
+          <p:cNvPr id="4" name="Slide Image Placeholder 3"/>
+          <p:cNvSpPr>
+            <a:spLocks noGrp="1" noRot="1" noChangeAspect="1"/>
+          </p:cNvSpPr>
+          <p:nvPr>
+            <p:ph type="sldImg" idx="2"/>
+          </p:nvPr>
+        </p:nvSpPr>
+        <p:spPr>
+          <a:xfrm>
+            <a:off x="685800" y="1143000"/>
+            <a:ext cx="5486400" cy="3086100"/>
+          </a:xfrm>
+          <a:prstGeom prst="rect">
+            <a:avLst/>
+          </a:prstGeom>
+          <a:noFill/>
+          <a:ln w="12700">
+            <a:solidFill>
+              <a:prstClr val="black"/>
+            </a:solidFill>
+          </a:ln>
+        </p:spPr>
+        <p:txBody>
+          <a:bodyPr vert="horz" lIns="91440" tIns="45720" rIns="91440" bIns="45720" rtlCol="0" anchor="ctr"/>
+          <a:lstStyle/>
+          <a:p>
+            <a:endParaRPr lang="en-US"/>
+          </a:p>
+        </p:txBody>
+      </p:sp>
+      <p:sp>
+        <p:nvSpPr>
+          <p:cNvPr id="5" name="Notes Placeholder 4"/>
+          <p:cNvSpPr>
+            <a:spLocks noGrp="1"/>
+          </p:cNvSpPr>
+          <p:nvPr>
+            <p:ph type="body" sz="quarter" idx="3"/>
+          </p:nvPr>
+        </p:nvSpPr>
+        <p:spPr>
+          <a:xfrm>
+            <a:off x="685800" y="4400550"/>
+            <a:ext cx="5486400" cy="3600450"/>
+          </a:xfrm>
+          <a:prstGeom prst="rect">
+            <a:avLst/>
+          </a:prstGeom>
+        </p:spPr>
+        <p:txBody>
+          <a:bodyPr vert="horz" lIns="91440" tIns="45720" rIns="91440" bIns="45720" rtlCol="0"/>
+          <a:lstStyle/>
+          <a:p>
+            <a:pPr lvl="0"/>
+            <a:r>
+              <a:rPr lang="en-US"/>
+              <a:t>Click to edit Master text styles</a:t>
+            </a:r>
+          </a:p>
+          <a:p>
+            <a:pPr lvl="1"/>
+            <a:r>
+              <a:rPr lang="en-US"/>
+              <a:t>Second level</a:t>
+            </a:r>
+          </a:p>
+          <a:p>
+            <a:pPr lvl="2"/>
+            <a:r>
+              <a:rPr lang="en-US"/>
+              <a:t>Third level</a:t>
+            </a:r>
+          </a:p>
+          <a:p>
+            <a:pPr lvl="3"/>
+            <a:r>
+              <a:rPr lang="en-US"/>
+              <a:t>Fourth level</a:t>
+            </a:r>
+          </a:p>
+          <a:p>
+            <a:pPr lvl="4"/>
+            <a:r>
+              <a:rPr lang="en-US"/>
+              <a:t>Fifth level</a:t>
+            </a:r>
+          </a:p>
+        </p:txBody>
+      </p:sp>
+      <p:sp>
+        <p:nvSpPr>
+          <p:cNvPr id="6" name="Footer Placeholder 5"/>
+          <p:cNvSpPr>
+            <a:spLocks noGrp="1"/>
+          </p:cNvSpPr>
+          <p:nvPr>
+            <p:ph type="ftr" sz="quarter" idx="4"/>
+          </p:nvPr>
+        </p:nvSpPr>
+        <p:spPr>
+          <a:xfrm>
+            <a:off x="0" y="8685213"/>
+            <a:ext cx="2971800" cy="458787"/>
+          </a:xfrm>
+          <a:prstGeom prst="rect">
+            <a:avLst/>
+          </a:prstGeom>
+        </p:spPr>
+        <p:txBody>
+          <a:bodyPr vert="horz" lIns="91440" tIns="45720" rIns="91440" bIns="45720" rtlCol="0" anchor="b"/>
+          <a:lstStyle>
+            <a:lvl1pPr algn="l">
+              <a:defRPr sz="1200"/>
+            </a:lvl1pPr>
+          </a:lstStyle>
+          <a:p>
+            <a:endParaRPr lang="en-US"/>
+          </a:p>
+        </p:txBody>
+      </p:sp>
+      <p:sp>
+        <p:nvSpPr>
+          <p:cNvPr id="7" name="Slide Number Placeholder 6"/>
+          <p:cNvSpPr>
+            <a:spLocks noGrp="1"/>
+          </p:cNvSpPr>
+          <p:nvPr>
+            <p:ph type="sldNum" sz="quarter" idx="5"/>
+          </p:nvPr>
+        </p:nvSpPr>
+        <p:spPr>
+          <a:xfrm>
+            <a:off x="3884613" y="8685213"/>
+            <a:ext cx="2971800" cy="458787"/>
+          </a:xfrm>
+          <a:prstGeom prst="rect">
+            <a:avLst/>
+          </a:prstGeom>
+        </p:spPr>
+        <p:txBody>
+          <a:bodyPr vert="horz" lIns="91440" tIns="45720" rIns="91440" bIns="45720" rtlCol="0" anchor="b"/>
+          <a:lstStyle>
+            <a:lvl1pPr algn="r">
+              <a:defRPr sz="1200"/>
+            </a:lvl1pPr>
+          </a:lstStyle>
+          <a:p>
+            <a:fld id="{69C0FCFF-8576-AC47-B4BB-9ED53EAEAC0D}" type="slidenum">
+              <a:rPr lang="en-US" smtClean="0"/>
+              <a:t>‹#›</a:t>
+            </a:fld>
+            <a:endParaRPr lang="en-US"/>
+          </a:p>
+        </p:txBody>
+      </p:sp>
+    </p:spTree>
+    <p:extLst>
+      <p:ext uri="{BB962C8B-B14F-4D97-AF65-F5344CB8AC3E}">
+        <p14:creationId xmlns:p14="http://schemas.microsoft.com/office/powerpoint/2010/main" val="2027035753"/>
+      </p:ext>
+    </p:extLst>
+  </p:cSld>
+  <p:clrMap bg1="lt1" tx1="dk1" bg2="lt2" tx2="dk2" accent1="accent1" accent2="accent2" accent3="accent3" accent4="accent4" accent5="accent5" accent6="accent6" hlink="hlink" folHlink="folHlink"/>
+  <p:notesStyle>
+    <a:lvl1pPr marL="0" algn="l" defTabSz="914400" rtl="0" eaLnBrk="1" latinLnBrk="0" hangingPunct="1">
+      <a:defRPr sz="1200" kern="1200">
+        <a:solidFill>
+          <a:schemeClr val="tx1"/>
+        </a:solidFill>
+        <a:latin typeface="+mn-lt"/>
+        <a:ea typeface="+mn-ea"/>
+        <a:cs typeface="+mn-cs"/>
+      </a:defRPr>
+    </a:lvl1pPr>
+    <a:lvl2pPr marL="457200" algn="l" defTabSz="914400" rtl="0" eaLnBrk="1" latinLnBrk="0" hangingPunct="1">
+      <a:defRPr sz="1200" kern="1200">
+        <a:solidFill>
+          <a:schemeClr val="tx1"/>
+        </a:solidFill>
+        <a:latin typeface="+mn-lt"/>
+        <a:ea typeface="+mn-ea"/>
+        <a:cs typeface="+mn-cs"/>
+      </a:defRPr>
+    </a:lvl2pPr>
+    <a:lvl3pPr marL="914400" algn="l" defTabSz="914400" rtl="0" eaLnBrk="1" latinLnBrk="0" hangingPunct="1">
+      <a:defRPr sz="1200" kern="1200">
+        <a:solidFill>
+          <a:schemeClr val="tx1"/>
+        </a:solidFill>
+        <a:latin typeface="+mn-lt"/>
+        <a:ea typeface="+mn-ea"/>
+        <a:cs typeface="+mn-cs"/>
+      </a:defRPr>
+    </a:lvl3pPr>
+    <a:lvl4pPr marL="1371600" algn="l" defTabSz="914400" rtl="0" eaLnBrk="1" latinLnBrk="0" hangingPunct="1">
+      <a:defRPr sz="1200" kern="1200">
+        <a:solidFill>
+          <a:schemeClr val="tx1"/>
+        </a:solidFill>
+        <a:latin typeface="+mn-lt"/>
+        <a:ea typeface="+mn-ea"/>
+        <a:cs typeface="+mn-cs"/>
+      </a:defRPr>
+    </a:lvl4pPr>
+    <a:lvl5pPr marL="1828800" algn="l" defTabSz="914400" rtl="0" eaLnBrk="1" latinLnBrk="0" hangingPunct="1">
+      <a:defRPr sz="1200" kern="1200">
+        <a:solidFill>
+          <a:schemeClr val="tx1"/>
+        </a:solidFill>
+        <a:latin typeface="+mn-lt"/>
+        <a:ea typeface="+mn-ea"/>
+        <a:cs typeface="+mn-cs"/>
+      </a:defRPr>
+    </a:lvl5pPr>
+    <a:lvl6pPr marL="2286000" algn="l" defTabSz="914400" rtl="0" eaLnBrk="1" latinLnBrk="0" hangingPunct="1">
+      <a:defRPr sz="1200" kern="1200">
+        <a:solidFill>
+          <a:schemeClr val="tx1"/>
+        </a:solidFill>
+        <a:latin typeface="+mn-lt"/>
+        <a:ea typeface="+mn-ea"/>
+        <a:cs typeface="+mn-cs"/>
+      </a:defRPr>
+    </a:lvl6pPr>
+    <a:lvl7pPr marL="2743200" algn="l" defTabSz="914400" rtl="0" eaLnBrk="1" latinLnBrk="0" hangingPunct="1">
+      <a:defRPr sz="1200" kern="1200">
+        <a:solidFill>
+          <a:schemeClr val="tx1"/>
+        </a:solidFill>
+        <a:latin typeface="+mn-lt"/>
+        <a:ea typeface="+mn-ea"/>
+        <a:cs typeface="+mn-cs"/>
+      </a:defRPr>
+    </a:lvl7pPr>
+    <a:lvl8pPr marL="3200400" algn="l" defTabSz="914400" rtl="0" eaLnBrk="1" latinLnBrk="0" hangingPunct="1">
+      <a:defRPr sz="1200" kern="1200">
+        <a:solidFill>
+          <a:schemeClr val="tx1"/>
+        </a:solidFill>
+        <a:latin typeface="+mn-lt"/>
+        <a:ea typeface="+mn-ea"/>
+        <a:cs typeface="+mn-cs"/>
+      </a:defRPr>
+    </a:lvl8pPr>
+    <a:lvl9pPr marL="3657600" algn="l" defTabSz="914400" rtl="0" eaLnBrk="1" latinLnBrk="0" hangingPunct="1">
+      <a:defRPr sz="1200" kern="1200">
+        <a:solidFill>
+          <a:schemeClr val="tx1"/>
+        </a:solidFill>
+        <a:latin typeface="+mn-lt"/>
+        <a:ea typeface="+mn-ea"/>
+        <a:cs typeface="+mn-cs"/>
+      </a:defRPr>
+    </a:lvl9pPr>
+  </p:notesStyle>
+</p:notesMaster>
+</file>
+
+<file path=ppt/notesSlides/notesSlide1.xml><?xml version="1.0" encoding="utf-8"?>
+<p:notes xmlns:a="http://schemas.openxmlformats.org/drawingml/2006/main" xmlns:r="http://schemas.openxmlformats.org/officeDocument/2006/relationships" xmlns:p="http://schemas.openxmlformats.org/presentationml/2006/main">
+  <p:cSld>
+    <p:spTree>
+      <p:nvGrpSpPr>
+        <p:cNvPr id="1" name=""/>
+        <p:cNvGrpSpPr/>
+        <p:nvPr/>
+      </p:nvGrpSpPr>
+      <p:grpSpPr>
+        <a:xfrm>
+          <a:off x="0" y="0"/>
+          <a:ext cx="0" cy="0"/>
+          <a:chOff x="0" y="0"/>
+          <a:chExt cx="0" cy="0"/>
+        </a:xfrm>
+      </p:grpSpPr>
+      <p:sp>
+        <p:nvSpPr>
+          <p:cNvPr id="2" name="Slide Image Placeholder 1"/>
+          <p:cNvSpPr>
+            <a:spLocks noGrp="1" noRot="1" noChangeAspect="1"/>
+          </p:cNvSpPr>
+          <p:nvPr>
+            <p:ph type="sldImg"/>
+          </p:nvPr>
+        </p:nvSpPr>
+        <p:spPr/>
+      </p:sp>
+      <p:sp>
+        <p:nvSpPr>
+          <p:cNvPr id="3" name="Notes Placeholder 2"/>
+          <p:cNvSpPr>
+            <a:spLocks noGrp="1"/>
+          </p:cNvSpPr>
+          <p:nvPr>
+            <p:ph type="body" idx="1"/>
+          </p:nvPr>
+        </p:nvSpPr>
+        <p:spPr/>
+        <p:txBody>
+          <a:bodyPr/>
+          <a:lstStyle/>
+          <a:p>
+            <a:endParaRPr lang="en-US" dirty="0"/>
+          </a:p>
+        </p:txBody>
+      </p:sp>
+      <p:sp>
+        <p:nvSpPr>
+          <p:cNvPr id="4" name="Slide Number Placeholder 3"/>
+          <p:cNvSpPr>
+            <a:spLocks noGrp="1"/>
+          </p:cNvSpPr>
+          <p:nvPr>
+            <p:ph type="sldNum" sz="quarter" idx="5"/>
+          </p:nvPr>
+        </p:nvSpPr>
+        <p:spPr/>
+        <p:txBody>
+          <a:bodyPr/>
+          <a:lstStyle/>
+          <a:p>
+            <a:fld id="{69C0FCFF-8576-AC47-B4BB-9ED53EAEAC0D}" type="slidenum">
+              <a:rPr lang="en-US" smtClean="0"/>
+              <a:t>4</a:t>
+            </a:fld>
+            <a:endParaRPr lang="en-US"/>
+          </a:p>
+        </p:txBody>
+      </p:sp>
+    </p:spTree>
+    <p:extLst>
+      <p:ext uri="{BB962C8B-B14F-4D97-AF65-F5344CB8AC3E}">
+        <p14:creationId xmlns:p14="http://schemas.microsoft.com/office/powerpoint/2010/main" val="3540122700"/>
+      </p:ext>
+    </p:extLst>
+  </p:cSld>
+  <p:clrMapOvr>
+    <a:masterClrMapping/>
+  </p:clrMapOvr>
+</p:notes>
 </file>
 
 <file path=ppt/slideLayouts/slideLayout1.xml><?xml version="1.0" encoding="utf-8"?>
@@ -263,7 +874,7 @@
           <a:p>
             <a:fld id="{57B7D466-2176-594C-A3A6-BDA60F406C09}" type="datetimeFigureOut">
               <a:rPr lang="en-US" smtClean="0"/>
-              <a:t>7/27/26</a:t>
+              <a:t>7/28/26</a:t>
             </a:fld>
             <a:endParaRPr lang="en-US"/>
           </a:p>
@@ -461,7 +1072,7 @@
           <a:p>
             <a:fld id="{57B7D466-2176-594C-A3A6-BDA60F406C09}" type="datetimeFigureOut">
               <a:rPr lang="en-US" smtClean="0"/>
-              <a:t>7/27/26</a:t>
+              <a:t>7/28/26</a:t>
             </a:fld>
             <a:endParaRPr lang="en-US"/>
           </a:p>
@@ -669,7 +1280,7 @@
           <a:p>
             <a:fld id="{57B7D466-2176-594C-A3A6-BDA60F406C09}" type="datetimeFigureOut">
               <a:rPr lang="en-US" smtClean="0"/>
-              <a:t>7/27/26</a:t>
+              <a:t>7/28/26</a:t>
             </a:fld>
             <a:endParaRPr lang="en-US"/>
           </a:p>
@@ -867,7 +1478,7 @@
           <a:p>
             <a:fld id="{57B7D466-2176-594C-A3A6-BDA60F406C09}" type="datetimeFigureOut">
               <a:rPr lang="en-US" smtClean="0"/>
-              <a:t>7/27/26</a:t>
+              <a:t>7/28/26</a:t>
             </a:fld>
             <a:endParaRPr lang="en-US"/>
           </a:p>
@@ -1142,7 +1753,7 @@
           <a:p>
             <a:fld id="{57B7D466-2176-594C-A3A6-BDA60F406C09}" type="datetimeFigureOut">
               <a:rPr lang="en-US" smtClean="0"/>
-              <a:t>7/27/26</a:t>
+              <a:t>7/28/26</a:t>
             </a:fld>
             <a:endParaRPr lang="en-US"/>
           </a:p>
@@ -1407,7 +2018,7 @@
           <a:p>
             <a:fld id="{57B7D466-2176-594C-A3A6-BDA60F406C09}" type="datetimeFigureOut">
               <a:rPr lang="en-US" smtClean="0"/>
-              <a:t>7/27/26</a:t>
+              <a:t>7/28/26</a:t>
             </a:fld>
             <a:endParaRPr lang="en-US"/>
           </a:p>
@@ -1819,7 +2430,7 @@
           <a:p>
             <a:fld id="{57B7D466-2176-594C-A3A6-BDA60F406C09}" type="datetimeFigureOut">
               <a:rPr lang="en-US" smtClean="0"/>
-              <a:t>7/27/26</a:t>
+              <a:t>7/28/26</a:t>
             </a:fld>
             <a:endParaRPr lang="en-US"/>
           </a:p>
@@ -1960,7 +2571,7 @@
           <a:p>
             <a:fld id="{57B7D466-2176-594C-A3A6-BDA60F406C09}" type="datetimeFigureOut">
               <a:rPr lang="en-US" smtClean="0"/>
-              <a:t>7/27/26</a:t>
+              <a:t>7/28/26</a:t>
             </a:fld>
             <a:endParaRPr lang="en-US"/>
           </a:p>
@@ -2073,7 +2684,7 @@
           <a:p>
             <a:fld id="{57B7D466-2176-594C-A3A6-BDA60F406C09}" type="datetimeFigureOut">
               <a:rPr lang="en-US" smtClean="0"/>
-              <a:t>7/27/26</a:t>
+              <a:t>7/28/26</a:t>
             </a:fld>
             <a:endParaRPr lang="en-US"/>
           </a:p>
@@ -2384,7 +2995,7 @@
           <a:p>
             <a:fld id="{57B7D466-2176-594C-A3A6-BDA60F406C09}" type="datetimeFigureOut">
               <a:rPr lang="en-US" smtClean="0"/>
-              <a:t>7/27/26</a:t>
+              <a:t>7/28/26</a:t>
             </a:fld>
             <a:endParaRPr lang="en-US"/>
           </a:p>
@@ -2672,7 +3283,7 @@
           <a:p>
             <a:fld id="{57B7D466-2176-594C-A3A6-BDA60F406C09}" type="datetimeFigureOut">
               <a:rPr lang="en-US" smtClean="0"/>
-              <a:t>7/27/26</a:t>
+              <a:t>7/28/26</a:t>
             </a:fld>
             <a:endParaRPr lang="en-US"/>
           </a:p>
@@ -2913,7 +3524,7 @@
           <a:p>
             <a:fld id="{57B7D466-2176-594C-A3A6-BDA60F406C09}" type="datetimeFigureOut">
               <a:rPr lang="en-US" smtClean="0"/>
-              <a:t>7/27/26</a:t>
+              <a:t>7/28/26</a:t>
             </a:fld>
             <a:endParaRPr lang="en-US"/>
           </a:p>
@@ -3404,7 +4015,13 @@
   <p:cSld>
     <p:spTree>
       <p:nvGrpSpPr>
-        <p:cNvPr id="1" name=""/>
+        <p:cNvPr id="1" name="">
+          <a:extLst>
+            <a:ext uri="{FF2B5EF4-FFF2-40B4-BE49-F238E27FC236}">
+              <a16:creationId xmlns:a16="http://schemas.microsoft.com/office/drawing/2014/main" id="{A6E0F2E0-31ED-0C0E-3FA7-0DAA6219C2A2}"/>
+            </a:ext>
+          </a:extLst>
+        </p:cNvPr>
         <p:cNvGrpSpPr/>
         <p:nvPr/>
       </p:nvGrpSpPr>
@@ -3421,7 +4038,7 @@
           <p:cNvPr id="2" name="Title 1">
             <a:extLst>
               <a:ext uri="{FF2B5EF4-FFF2-40B4-BE49-F238E27FC236}">
-                <a16:creationId xmlns:a16="http://schemas.microsoft.com/office/drawing/2014/main" id="{4183DAA3-1BDC-FDE3-C2E7-CBE1756A1FF4}"/>
+                <a16:creationId xmlns:a16="http://schemas.microsoft.com/office/drawing/2014/main" id="{654DBA5C-63EE-FE2E-66F8-F5D3804DE497}"/>
               </a:ext>
             </a:extLst>
           </p:cNvPr>
@@ -3439,7 +4056,7 @@
           <a:p>
             <a:r>
               <a:rPr lang="en-US" dirty="0"/>
-              <a:t>Educational journey</a:t>
+              <a:t>Challenges &amp; growth</a:t>
             </a:r>
           </a:p>
         </p:txBody>
@@ -3449,7 +4066,7 @@
           <p:cNvPr id="3" name="Content Placeholder 2">
             <a:extLst>
               <a:ext uri="{FF2B5EF4-FFF2-40B4-BE49-F238E27FC236}">
-                <a16:creationId xmlns:a16="http://schemas.microsoft.com/office/drawing/2014/main" id="{D89A5F97-99F1-65C1-2DD5-1204FFF557B0}"/>
+                <a16:creationId xmlns:a16="http://schemas.microsoft.com/office/drawing/2014/main" id="{E9434E4C-9C1C-5EB8-A236-7C418A41563D}"/>
               </a:ext>
             </a:extLst>
           </p:cNvPr>
@@ -3460,19 +4077,656 @@
             <p:ph idx="1"/>
           </p:nvPr>
         </p:nvSpPr>
-        <p:spPr/>
-        <p:txBody>
-          <a:bodyPr/>
-          <a:lstStyle/>
-          <a:p>
-            <a:endParaRPr lang="en-US"/>
+        <p:spPr>
+          <a:xfrm>
+            <a:off x="838200" y="1528219"/>
+            <a:ext cx="10515600" cy="1463175"/>
+          </a:xfrm>
+        </p:spPr>
+        <p:txBody>
+          <a:bodyPr/>
+          <a:lstStyle/>
+          <a:p>
+            <a:r>
+              <a:rPr lang="en-US" dirty="0"/>
+              <a:t>What was one of the biggest challenges you faced early in your career?</a:t>
+            </a:r>
+          </a:p>
+          <a:p>
+            <a:r>
+              <a:rPr lang="en-US" dirty="0"/>
+              <a:t>How did mentors or peers influence your journey?</a:t>
+            </a:r>
+          </a:p>
+        </p:txBody>
+      </p:sp>
+      <p:sp>
+        <p:nvSpPr>
+          <p:cNvPr id="4" name="Title 1">
+            <a:extLst>
+              <a:ext uri="{FF2B5EF4-FFF2-40B4-BE49-F238E27FC236}">
+                <a16:creationId xmlns:a16="http://schemas.microsoft.com/office/drawing/2014/main" id="{18FA6F38-DBA6-46A7-4B82-E1A03E456F72}"/>
+              </a:ext>
+            </a:extLst>
+          </p:cNvPr>
+          <p:cNvSpPr txBox="1">
+            <a:spLocks/>
+          </p:cNvSpPr>
+          <p:nvPr/>
+        </p:nvSpPr>
+        <p:spPr>
+          <a:xfrm>
+            <a:off x="838200" y="3429000"/>
+            <a:ext cx="10515600" cy="1325563"/>
+          </a:xfrm>
+          <a:prstGeom prst="rect">
+            <a:avLst/>
+          </a:prstGeom>
+        </p:spPr>
+        <p:txBody>
+          <a:bodyPr vert="horz" lIns="91440" tIns="45720" rIns="91440" bIns="45720" rtlCol="0" anchor="ctr">
+            <a:normAutofit/>
+          </a:bodyPr>
+          <a:lstStyle>
+            <a:lvl1pPr algn="l" defTabSz="914400" rtl="0" eaLnBrk="1" latinLnBrk="0" hangingPunct="1">
+              <a:lnSpc>
+                <a:spcPct val="90000"/>
+              </a:lnSpc>
+              <a:spcBef>
+                <a:spcPct val="0"/>
+              </a:spcBef>
+              <a:buNone/>
+              <a:defRPr sz="4400" kern="1200">
+                <a:solidFill>
+                  <a:schemeClr val="tx1"/>
+                </a:solidFill>
+                <a:latin typeface="+mj-lt"/>
+                <a:ea typeface="+mj-ea"/>
+                <a:cs typeface="+mj-cs"/>
+              </a:defRPr>
+            </a:lvl1pPr>
+          </a:lstStyle>
+          <a:p>
+            <a:r>
+              <a:rPr lang="en-US" dirty="0"/>
+              <a:t>Career exploration</a:t>
+            </a:r>
+          </a:p>
+        </p:txBody>
+      </p:sp>
+      <p:sp>
+        <p:nvSpPr>
+          <p:cNvPr id="5" name="Content Placeholder 2">
+            <a:extLst>
+              <a:ext uri="{FF2B5EF4-FFF2-40B4-BE49-F238E27FC236}">
+                <a16:creationId xmlns:a16="http://schemas.microsoft.com/office/drawing/2014/main" id="{14E739C5-9421-528C-C2E0-EE33D4E99E48}"/>
+              </a:ext>
+            </a:extLst>
+          </p:cNvPr>
+          <p:cNvSpPr txBox="1">
+            <a:spLocks/>
+          </p:cNvSpPr>
+          <p:nvPr/>
+        </p:nvSpPr>
+        <p:spPr>
+          <a:xfrm>
+            <a:off x="838200" y="4529389"/>
+            <a:ext cx="10515600" cy="1463175"/>
+          </a:xfrm>
+          <a:prstGeom prst="rect">
+            <a:avLst/>
+          </a:prstGeom>
+        </p:spPr>
+        <p:txBody>
+          <a:bodyPr vert="horz" lIns="91440" tIns="45720" rIns="91440" bIns="45720" rtlCol="0">
+            <a:normAutofit/>
+          </a:bodyPr>
+          <a:lstStyle>
+            <a:lvl1pPr marL="228600" indent="-228600" algn="l" defTabSz="914400" rtl="0" eaLnBrk="1" latinLnBrk="0" hangingPunct="1">
+              <a:lnSpc>
+                <a:spcPct val="90000"/>
+              </a:lnSpc>
+              <a:spcBef>
+                <a:spcPts val="1000"/>
+              </a:spcBef>
+              <a:buFont typeface="Arial" panose="020B0604020202020204" pitchFamily="34" charset="0"/>
+              <a:buChar char="•"/>
+              <a:defRPr sz="2800" kern="1200">
+                <a:solidFill>
+                  <a:schemeClr val="tx1"/>
+                </a:solidFill>
+                <a:latin typeface="+mn-lt"/>
+                <a:ea typeface="+mn-ea"/>
+                <a:cs typeface="+mn-cs"/>
+              </a:defRPr>
+            </a:lvl1pPr>
+            <a:lvl2pPr marL="685800" indent="-228600" algn="l" defTabSz="914400" rtl="0" eaLnBrk="1" latinLnBrk="0" hangingPunct="1">
+              <a:lnSpc>
+                <a:spcPct val="90000"/>
+              </a:lnSpc>
+              <a:spcBef>
+                <a:spcPts val="500"/>
+              </a:spcBef>
+              <a:buFont typeface="Arial" panose="020B0604020202020204" pitchFamily="34" charset="0"/>
+              <a:buChar char="•"/>
+              <a:defRPr sz="2400" kern="1200">
+                <a:solidFill>
+                  <a:schemeClr val="tx1"/>
+                </a:solidFill>
+                <a:latin typeface="+mn-lt"/>
+                <a:ea typeface="+mn-ea"/>
+                <a:cs typeface="+mn-cs"/>
+              </a:defRPr>
+            </a:lvl2pPr>
+            <a:lvl3pPr marL="1143000" indent="-228600" algn="l" defTabSz="914400" rtl="0" eaLnBrk="1" latinLnBrk="0" hangingPunct="1">
+              <a:lnSpc>
+                <a:spcPct val="90000"/>
+              </a:lnSpc>
+              <a:spcBef>
+                <a:spcPts val="500"/>
+              </a:spcBef>
+              <a:buFont typeface="Arial" panose="020B0604020202020204" pitchFamily="34" charset="0"/>
+              <a:buChar char="•"/>
+              <a:defRPr sz="2000" kern="1200">
+                <a:solidFill>
+                  <a:schemeClr val="tx1"/>
+                </a:solidFill>
+                <a:latin typeface="+mn-lt"/>
+                <a:ea typeface="+mn-ea"/>
+                <a:cs typeface="+mn-cs"/>
+              </a:defRPr>
+            </a:lvl3pPr>
+            <a:lvl4pPr marL="1600200" indent="-228600" algn="l" defTabSz="914400" rtl="0" eaLnBrk="1" latinLnBrk="0" hangingPunct="1">
+              <a:lnSpc>
+                <a:spcPct val="90000"/>
+              </a:lnSpc>
+              <a:spcBef>
+                <a:spcPts val="500"/>
+              </a:spcBef>
+              <a:buFont typeface="Arial" panose="020B0604020202020204" pitchFamily="34" charset="0"/>
+              <a:buChar char="•"/>
+              <a:defRPr sz="1800" kern="1200">
+                <a:solidFill>
+                  <a:schemeClr val="tx1"/>
+                </a:solidFill>
+                <a:latin typeface="+mn-lt"/>
+                <a:ea typeface="+mn-ea"/>
+                <a:cs typeface="+mn-cs"/>
+              </a:defRPr>
+            </a:lvl4pPr>
+            <a:lvl5pPr marL="2057400" indent="-228600" algn="l" defTabSz="914400" rtl="0" eaLnBrk="1" latinLnBrk="0" hangingPunct="1">
+              <a:lnSpc>
+                <a:spcPct val="90000"/>
+              </a:lnSpc>
+              <a:spcBef>
+                <a:spcPts val="500"/>
+              </a:spcBef>
+              <a:buFont typeface="Arial" panose="020B0604020202020204" pitchFamily="34" charset="0"/>
+              <a:buChar char="•"/>
+              <a:defRPr sz="1800" kern="1200">
+                <a:solidFill>
+                  <a:schemeClr val="tx1"/>
+                </a:solidFill>
+                <a:latin typeface="+mn-lt"/>
+                <a:ea typeface="+mn-ea"/>
+                <a:cs typeface="+mn-cs"/>
+              </a:defRPr>
+            </a:lvl5pPr>
+            <a:lvl6pPr marL="2514600" indent="-228600" algn="l" defTabSz="914400" rtl="0" eaLnBrk="1" latinLnBrk="0" hangingPunct="1">
+              <a:lnSpc>
+                <a:spcPct val="90000"/>
+              </a:lnSpc>
+              <a:spcBef>
+                <a:spcPts val="500"/>
+              </a:spcBef>
+              <a:buFont typeface="Arial" panose="020B0604020202020204" pitchFamily="34" charset="0"/>
+              <a:buChar char="•"/>
+              <a:defRPr sz="1800" kern="1200">
+                <a:solidFill>
+                  <a:schemeClr val="tx1"/>
+                </a:solidFill>
+                <a:latin typeface="+mn-lt"/>
+                <a:ea typeface="+mn-ea"/>
+                <a:cs typeface="+mn-cs"/>
+              </a:defRPr>
+            </a:lvl6pPr>
+            <a:lvl7pPr marL="2971800" indent="-228600" algn="l" defTabSz="914400" rtl="0" eaLnBrk="1" latinLnBrk="0" hangingPunct="1">
+              <a:lnSpc>
+                <a:spcPct val="90000"/>
+              </a:lnSpc>
+              <a:spcBef>
+                <a:spcPts val="500"/>
+              </a:spcBef>
+              <a:buFont typeface="Arial" panose="020B0604020202020204" pitchFamily="34" charset="0"/>
+              <a:buChar char="•"/>
+              <a:defRPr sz="1800" kern="1200">
+                <a:solidFill>
+                  <a:schemeClr val="tx1"/>
+                </a:solidFill>
+                <a:latin typeface="+mn-lt"/>
+                <a:ea typeface="+mn-ea"/>
+                <a:cs typeface="+mn-cs"/>
+              </a:defRPr>
+            </a:lvl7pPr>
+            <a:lvl8pPr marL="3429000" indent="-228600" algn="l" defTabSz="914400" rtl="0" eaLnBrk="1" latinLnBrk="0" hangingPunct="1">
+              <a:lnSpc>
+                <a:spcPct val="90000"/>
+              </a:lnSpc>
+              <a:spcBef>
+                <a:spcPts val="500"/>
+              </a:spcBef>
+              <a:buFont typeface="Arial" panose="020B0604020202020204" pitchFamily="34" charset="0"/>
+              <a:buChar char="•"/>
+              <a:defRPr sz="1800" kern="1200">
+                <a:solidFill>
+                  <a:schemeClr val="tx1"/>
+                </a:solidFill>
+                <a:latin typeface="+mn-lt"/>
+                <a:ea typeface="+mn-ea"/>
+                <a:cs typeface="+mn-cs"/>
+              </a:defRPr>
+            </a:lvl8pPr>
+            <a:lvl9pPr marL="3886200" indent="-228600" algn="l" defTabSz="914400" rtl="0" eaLnBrk="1" latinLnBrk="0" hangingPunct="1">
+              <a:lnSpc>
+                <a:spcPct val="90000"/>
+              </a:lnSpc>
+              <a:spcBef>
+                <a:spcPts val="500"/>
+              </a:spcBef>
+              <a:buFont typeface="Arial" panose="020B0604020202020204" pitchFamily="34" charset="0"/>
+              <a:buChar char="•"/>
+              <a:defRPr sz="1800" kern="1200">
+                <a:solidFill>
+                  <a:schemeClr val="tx1"/>
+                </a:solidFill>
+                <a:latin typeface="+mn-lt"/>
+                <a:ea typeface="+mn-ea"/>
+                <a:cs typeface="+mn-cs"/>
+              </a:defRPr>
+            </a:lvl9pPr>
+          </a:lstStyle>
+          <a:p>
+            <a:r>
+              <a:rPr lang="en-US" dirty="0"/>
+              <a:t>How did you find your current position?</a:t>
+            </a:r>
+          </a:p>
+          <a:p>
+            <a:r>
+              <a:rPr lang="en-US" dirty="0"/>
+              <a:t>What opportunities exist in your field that students might not know about?</a:t>
+            </a:r>
           </a:p>
         </p:txBody>
       </p:sp>
     </p:spTree>
     <p:extLst>
       <p:ext uri="{BB962C8B-B14F-4D97-AF65-F5344CB8AC3E}">
-        <p14:creationId xmlns:p14="http://schemas.microsoft.com/office/powerpoint/2010/main" val="462227079"/>
+        <p14:creationId xmlns:p14="http://schemas.microsoft.com/office/powerpoint/2010/main" val="2292381515"/>
+      </p:ext>
+    </p:extLst>
+  </p:cSld>
+  <p:clrMapOvr>
+    <a:masterClrMapping/>
+  </p:clrMapOvr>
+</p:sld>
+</file>
+
+<file path=ppt/slides/slide11.xml><?xml version="1.0" encoding="utf-8"?>
+<p:sld xmlns:a="http://schemas.openxmlformats.org/drawingml/2006/main" xmlns:r="http://schemas.openxmlformats.org/officeDocument/2006/relationships" xmlns:p="http://schemas.openxmlformats.org/presentationml/2006/main">
+  <p:cSld>
+    <p:spTree>
+      <p:nvGrpSpPr>
+        <p:cNvPr id="1" name="">
+          <a:extLst>
+            <a:ext uri="{FF2B5EF4-FFF2-40B4-BE49-F238E27FC236}">
+              <a16:creationId xmlns:a16="http://schemas.microsoft.com/office/drawing/2014/main" id="{17E0AB3B-D27C-C922-C920-1CA2EB590108}"/>
+            </a:ext>
+          </a:extLst>
+        </p:cNvPr>
+        <p:cNvGrpSpPr/>
+        <p:nvPr/>
+      </p:nvGrpSpPr>
+      <p:grpSpPr>
+        <a:xfrm>
+          <a:off x="0" y="0"/>
+          <a:ext cx="0" cy="0"/>
+          <a:chOff x="0" y="0"/>
+          <a:chExt cx="0" cy="0"/>
+        </a:xfrm>
+      </p:grpSpPr>
+      <p:sp>
+        <p:nvSpPr>
+          <p:cNvPr id="2" name="Title 1">
+            <a:extLst>
+              <a:ext uri="{FF2B5EF4-FFF2-40B4-BE49-F238E27FC236}">
+                <a16:creationId xmlns:a16="http://schemas.microsoft.com/office/drawing/2014/main" id="{514B3BAF-7FAB-F0CC-C0B9-8D121D418F4C}"/>
+              </a:ext>
+            </a:extLst>
+          </p:cNvPr>
+          <p:cNvSpPr>
+            <a:spLocks noGrp="1"/>
+          </p:cNvSpPr>
+          <p:nvPr>
+            <p:ph type="title"/>
+          </p:nvPr>
+        </p:nvSpPr>
+        <p:spPr/>
+        <p:txBody>
+          <a:bodyPr/>
+          <a:lstStyle/>
+          <a:p>
+            <a:r>
+              <a:rPr lang="en-US" dirty="0"/>
+              <a:t>Skills &amp; advice</a:t>
+            </a:r>
+          </a:p>
+        </p:txBody>
+      </p:sp>
+      <p:sp>
+        <p:nvSpPr>
+          <p:cNvPr id="3" name="Content Placeholder 2">
+            <a:extLst>
+              <a:ext uri="{FF2B5EF4-FFF2-40B4-BE49-F238E27FC236}">
+                <a16:creationId xmlns:a16="http://schemas.microsoft.com/office/drawing/2014/main" id="{1994A921-34B1-1628-EEDA-7FA957E9FFD2}"/>
+              </a:ext>
+            </a:extLst>
+          </p:cNvPr>
+          <p:cNvSpPr>
+            <a:spLocks noGrp="1"/>
+          </p:cNvSpPr>
+          <p:nvPr>
+            <p:ph idx="1"/>
+          </p:nvPr>
+        </p:nvSpPr>
+        <p:spPr>
+          <a:xfrm>
+            <a:off x="838200" y="1528219"/>
+            <a:ext cx="10515600" cy="1900781"/>
+          </a:xfrm>
+        </p:spPr>
+        <p:txBody>
+          <a:bodyPr>
+            <a:normAutofit/>
+          </a:bodyPr>
+          <a:lstStyle/>
+          <a:p>
+            <a:r>
+              <a:rPr lang="en-US" dirty="0"/>
+              <a:t>What skills are most important for students to develop? (technical and soft skills)</a:t>
+            </a:r>
+          </a:p>
+          <a:p>
+            <a:r>
+              <a:rPr lang="en-US" dirty="0"/>
+              <a:t>What experiences (internships, research, volunteering) would you recommend?</a:t>
+            </a:r>
+          </a:p>
+        </p:txBody>
+      </p:sp>
+      <p:sp>
+        <p:nvSpPr>
+          <p:cNvPr id="4" name="Title 1">
+            <a:extLst>
+              <a:ext uri="{FF2B5EF4-FFF2-40B4-BE49-F238E27FC236}">
+                <a16:creationId xmlns:a16="http://schemas.microsoft.com/office/drawing/2014/main" id="{101ACB80-9F02-10F1-A101-FE05D6095AE2}"/>
+              </a:ext>
+            </a:extLst>
+          </p:cNvPr>
+          <p:cNvSpPr txBox="1">
+            <a:spLocks/>
+          </p:cNvSpPr>
+          <p:nvPr/>
+        </p:nvSpPr>
+        <p:spPr>
+          <a:xfrm>
+            <a:off x="838200" y="3429000"/>
+            <a:ext cx="10515600" cy="1325563"/>
+          </a:xfrm>
+          <a:prstGeom prst="rect">
+            <a:avLst/>
+          </a:prstGeom>
+        </p:spPr>
+        <p:txBody>
+          <a:bodyPr vert="horz" lIns="91440" tIns="45720" rIns="91440" bIns="45720" rtlCol="0" anchor="ctr">
+            <a:normAutofit/>
+          </a:bodyPr>
+          <a:lstStyle>
+            <a:lvl1pPr algn="l" defTabSz="914400" rtl="0" eaLnBrk="1" latinLnBrk="0" hangingPunct="1">
+              <a:lnSpc>
+                <a:spcPct val="90000"/>
+              </a:lnSpc>
+              <a:spcBef>
+                <a:spcPct val="0"/>
+              </a:spcBef>
+              <a:buNone/>
+              <a:defRPr sz="4400" kern="1200">
+                <a:solidFill>
+                  <a:schemeClr val="tx1"/>
+                </a:solidFill>
+                <a:latin typeface="+mj-lt"/>
+                <a:ea typeface="+mj-ea"/>
+                <a:cs typeface="+mj-cs"/>
+              </a:defRPr>
+            </a:lvl1pPr>
+          </a:lstStyle>
+          <a:p>
+            <a:r>
+              <a:rPr lang="en-US" dirty="0"/>
+              <a:t>Personal perspective</a:t>
+            </a:r>
+          </a:p>
+        </p:txBody>
+      </p:sp>
+      <p:sp>
+        <p:nvSpPr>
+          <p:cNvPr id="5" name="Content Placeholder 2">
+            <a:extLst>
+              <a:ext uri="{FF2B5EF4-FFF2-40B4-BE49-F238E27FC236}">
+                <a16:creationId xmlns:a16="http://schemas.microsoft.com/office/drawing/2014/main" id="{4EF4ACAA-E279-DF29-A916-D10D6DBD8048}"/>
+              </a:ext>
+            </a:extLst>
+          </p:cNvPr>
+          <p:cNvSpPr txBox="1">
+            <a:spLocks/>
+          </p:cNvSpPr>
+          <p:nvPr/>
+        </p:nvSpPr>
+        <p:spPr>
+          <a:xfrm>
+            <a:off x="838200" y="4529389"/>
+            <a:ext cx="10515600" cy="1463175"/>
+          </a:xfrm>
+          <a:prstGeom prst="rect">
+            <a:avLst/>
+          </a:prstGeom>
+        </p:spPr>
+        <p:txBody>
+          <a:bodyPr vert="horz" lIns="91440" tIns="45720" rIns="91440" bIns="45720" rtlCol="0">
+            <a:normAutofit/>
+          </a:bodyPr>
+          <a:lstStyle>
+            <a:lvl1pPr marL="228600" indent="-228600" algn="l" defTabSz="914400" rtl="0" eaLnBrk="1" latinLnBrk="0" hangingPunct="1">
+              <a:lnSpc>
+                <a:spcPct val="90000"/>
+              </a:lnSpc>
+              <a:spcBef>
+                <a:spcPts val="1000"/>
+              </a:spcBef>
+              <a:buFont typeface="Arial" panose="020B0604020202020204" pitchFamily="34" charset="0"/>
+              <a:buChar char="•"/>
+              <a:defRPr sz="2800" kern="1200">
+                <a:solidFill>
+                  <a:schemeClr val="tx1"/>
+                </a:solidFill>
+                <a:latin typeface="+mn-lt"/>
+                <a:ea typeface="+mn-ea"/>
+                <a:cs typeface="+mn-cs"/>
+              </a:defRPr>
+            </a:lvl1pPr>
+            <a:lvl2pPr marL="685800" indent="-228600" algn="l" defTabSz="914400" rtl="0" eaLnBrk="1" latinLnBrk="0" hangingPunct="1">
+              <a:lnSpc>
+                <a:spcPct val="90000"/>
+              </a:lnSpc>
+              <a:spcBef>
+                <a:spcPts val="500"/>
+              </a:spcBef>
+              <a:buFont typeface="Arial" panose="020B0604020202020204" pitchFamily="34" charset="0"/>
+              <a:buChar char="•"/>
+              <a:defRPr sz="2400" kern="1200">
+                <a:solidFill>
+                  <a:schemeClr val="tx1"/>
+                </a:solidFill>
+                <a:latin typeface="+mn-lt"/>
+                <a:ea typeface="+mn-ea"/>
+                <a:cs typeface="+mn-cs"/>
+              </a:defRPr>
+            </a:lvl2pPr>
+            <a:lvl3pPr marL="1143000" indent="-228600" algn="l" defTabSz="914400" rtl="0" eaLnBrk="1" latinLnBrk="0" hangingPunct="1">
+              <a:lnSpc>
+                <a:spcPct val="90000"/>
+              </a:lnSpc>
+              <a:spcBef>
+                <a:spcPts val="500"/>
+              </a:spcBef>
+              <a:buFont typeface="Arial" panose="020B0604020202020204" pitchFamily="34" charset="0"/>
+              <a:buChar char="•"/>
+              <a:defRPr sz="2000" kern="1200">
+                <a:solidFill>
+                  <a:schemeClr val="tx1"/>
+                </a:solidFill>
+                <a:latin typeface="+mn-lt"/>
+                <a:ea typeface="+mn-ea"/>
+                <a:cs typeface="+mn-cs"/>
+              </a:defRPr>
+            </a:lvl3pPr>
+            <a:lvl4pPr marL="1600200" indent="-228600" algn="l" defTabSz="914400" rtl="0" eaLnBrk="1" latinLnBrk="0" hangingPunct="1">
+              <a:lnSpc>
+                <a:spcPct val="90000"/>
+              </a:lnSpc>
+              <a:spcBef>
+                <a:spcPts val="500"/>
+              </a:spcBef>
+              <a:buFont typeface="Arial" panose="020B0604020202020204" pitchFamily="34" charset="0"/>
+              <a:buChar char="•"/>
+              <a:defRPr sz="1800" kern="1200">
+                <a:solidFill>
+                  <a:schemeClr val="tx1"/>
+                </a:solidFill>
+                <a:latin typeface="+mn-lt"/>
+                <a:ea typeface="+mn-ea"/>
+                <a:cs typeface="+mn-cs"/>
+              </a:defRPr>
+            </a:lvl4pPr>
+            <a:lvl5pPr marL="2057400" indent="-228600" algn="l" defTabSz="914400" rtl="0" eaLnBrk="1" latinLnBrk="0" hangingPunct="1">
+              <a:lnSpc>
+                <a:spcPct val="90000"/>
+              </a:lnSpc>
+              <a:spcBef>
+                <a:spcPts val="500"/>
+              </a:spcBef>
+              <a:buFont typeface="Arial" panose="020B0604020202020204" pitchFamily="34" charset="0"/>
+              <a:buChar char="•"/>
+              <a:defRPr sz="1800" kern="1200">
+                <a:solidFill>
+                  <a:schemeClr val="tx1"/>
+                </a:solidFill>
+                <a:latin typeface="+mn-lt"/>
+                <a:ea typeface="+mn-ea"/>
+                <a:cs typeface="+mn-cs"/>
+              </a:defRPr>
+            </a:lvl5pPr>
+            <a:lvl6pPr marL="2514600" indent="-228600" algn="l" defTabSz="914400" rtl="0" eaLnBrk="1" latinLnBrk="0" hangingPunct="1">
+              <a:lnSpc>
+                <a:spcPct val="90000"/>
+              </a:lnSpc>
+              <a:spcBef>
+                <a:spcPts val="500"/>
+              </a:spcBef>
+              <a:buFont typeface="Arial" panose="020B0604020202020204" pitchFamily="34" charset="0"/>
+              <a:buChar char="•"/>
+              <a:defRPr sz="1800" kern="1200">
+                <a:solidFill>
+                  <a:schemeClr val="tx1"/>
+                </a:solidFill>
+                <a:latin typeface="+mn-lt"/>
+                <a:ea typeface="+mn-ea"/>
+                <a:cs typeface="+mn-cs"/>
+              </a:defRPr>
+            </a:lvl6pPr>
+            <a:lvl7pPr marL="2971800" indent="-228600" algn="l" defTabSz="914400" rtl="0" eaLnBrk="1" latinLnBrk="0" hangingPunct="1">
+              <a:lnSpc>
+                <a:spcPct val="90000"/>
+              </a:lnSpc>
+              <a:spcBef>
+                <a:spcPts val="500"/>
+              </a:spcBef>
+              <a:buFont typeface="Arial" panose="020B0604020202020204" pitchFamily="34" charset="0"/>
+              <a:buChar char="•"/>
+              <a:defRPr sz="1800" kern="1200">
+                <a:solidFill>
+                  <a:schemeClr val="tx1"/>
+                </a:solidFill>
+                <a:latin typeface="+mn-lt"/>
+                <a:ea typeface="+mn-ea"/>
+                <a:cs typeface="+mn-cs"/>
+              </a:defRPr>
+            </a:lvl7pPr>
+            <a:lvl8pPr marL="3429000" indent="-228600" algn="l" defTabSz="914400" rtl="0" eaLnBrk="1" latinLnBrk="0" hangingPunct="1">
+              <a:lnSpc>
+                <a:spcPct val="90000"/>
+              </a:lnSpc>
+              <a:spcBef>
+                <a:spcPts val="500"/>
+              </a:spcBef>
+              <a:buFont typeface="Arial" panose="020B0604020202020204" pitchFamily="34" charset="0"/>
+              <a:buChar char="•"/>
+              <a:defRPr sz="1800" kern="1200">
+                <a:solidFill>
+                  <a:schemeClr val="tx1"/>
+                </a:solidFill>
+                <a:latin typeface="+mn-lt"/>
+                <a:ea typeface="+mn-ea"/>
+                <a:cs typeface="+mn-cs"/>
+              </a:defRPr>
+            </a:lvl8pPr>
+            <a:lvl9pPr marL="3886200" indent="-228600" algn="l" defTabSz="914400" rtl="0" eaLnBrk="1" latinLnBrk="0" hangingPunct="1">
+              <a:lnSpc>
+                <a:spcPct val="90000"/>
+              </a:lnSpc>
+              <a:spcBef>
+                <a:spcPts val="500"/>
+              </a:spcBef>
+              <a:buFont typeface="Arial" panose="020B0604020202020204" pitchFamily="34" charset="0"/>
+              <a:buChar char="•"/>
+              <a:defRPr sz="1800" kern="1200">
+                <a:solidFill>
+                  <a:schemeClr val="tx1"/>
+                </a:solidFill>
+                <a:latin typeface="+mn-lt"/>
+                <a:ea typeface="+mn-ea"/>
+                <a:cs typeface="+mn-cs"/>
+              </a:defRPr>
+            </a:lvl9pPr>
+          </a:lstStyle>
+          <a:p>
+            <a:r>
+              <a:rPr lang="en-US" dirty="0"/>
+              <a:t>What keeps you motivated?</a:t>
+            </a:r>
+          </a:p>
+          <a:p>
+            <a:r>
+              <a:rPr lang="en-US" dirty="0"/>
+              <a:t>How do you balance work with your personal life?</a:t>
+            </a:r>
+          </a:p>
+        </p:txBody>
+      </p:sp>
+    </p:spTree>
+    <p:extLst>
+      <p:ext uri="{BB962C8B-B14F-4D97-AF65-F5344CB8AC3E}">
+        <p14:creationId xmlns:p14="http://schemas.microsoft.com/office/powerpoint/2010/main" val="186808384"/>
       </p:ext>
     </p:extLst>
   </p:cSld>
@@ -3680,7 +4934,7 @@
           <p:nvPr/>
         </p:nvPicPr>
         <p:blipFill>
-          <a:blip r:embed="rId2"/>
+          <a:blip r:embed="rId3"/>
           <a:stretch>
             <a:fillRect/>
           </a:stretch>
@@ -3710,7 +4964,7 @@
           <p:nvPr/>
         </p:nvPicPr>
         <p:blipFill>
-          <a:blip r:embed="rId3"/>
+          <a:blip r:embed="rId4"/>
           <a:stretch>
             <a:fillRect/>
           </a:stretch>
@@ -3740,7 +4994,7 @@
           <p:nvPr/>
         </p:nvPicPr>
         <p:blipFill>
-          <a:blip r:embed="rId4"/>
+          <a:blip r:embed="rId5"/>
           <a:stretch>
             <a:fillRect/>
           </a:stretch>
@@ -3770,7 +5024,7 @@
           <p:nvPr/>
         </p:nvPicPr>
         <p:blipFill>
-          <a:blip r:embed="rId5"/>
+          <a:blip r:embed="rId6"/>
           <a:srcRect l="23999" r="25924" b="12048"/>
           <a:stretch>
             <a:fillRect/>
@@ -3801,14 +5055,14 @@
           <p:nvPr/>
         </p:nvPicPr>
         <p:blipFill>
-          <a:blip r:embed="rId6"/>
+          <a:blip r:embed="rId7"/>
           <a:stretch>
             <a:fillRect/>
           </a:stretch>
         </p:blipFill>
         <p:spPr>
           <a:xfrm>
-            <a:off x="3211994" y="2691409"/>
+            <a:off x="2590931" y="2691409"/>
             <a:ext cx="2899992" cy="737591"/>
           </a:xfrm>
           <a:prstGeom prst="rect">
@@ -3831,7 +5085,7 @@
           <p:nvPr/>
         </p:nvPicPr>
         <p:blipFill>
-          <a:blip r:embed="rId7"/>
+          <a:blip r:embed="rId8"/>
           <a:srcRect t="31188" b="28721"/>
           <a:stretch>
             <a:fillRect/>
@@ -3862,7 +5116,7 @@
           <p:nvPr/>
         </p:nvPicPr>
         <p:blipFill>
-          <a:blip r:embed="rId8"/>
+          <a:blip r:embed="rId9"/>
           <a:stretch>
             <a:fillRect/>
           </a:stretch>
@@ -3920,15 +5174,46 @@
           <p:nvPr/>
         </p:nvPicPr>
         <p:blipFill>
-          <a:blip r:embed="rId9"/>
+          <a:blip r:embed="rId10"/>
+          <a:srcRect r="10643"/>
           <a:stretch>
             <a:fillRect/>
           </a:stretch>
         </p:blipFill>
         <p:spPr>
           <a:xfrm>
-            <a:off x="6917669" y="4647623"/>
-            <a:ext cx="1998826" cy="1998826"/>
+            <a:off x="7130390" y="4684530"/>
+            <a:ext cx="1786105" cy="1998826"/>
+          </a:xfrm>
+          <a:prstGeom prst="rect">
+            <a:avLst/>
+          </a:prstGeom>
+        </p:spPr>
+      </p:pic>
+      <p:pic>
+        <p:nvPicPr>
+          <p:cNvPr id="3" name="Picture 2" descr="Novo Nordisk - Wikipedia">
+            <a:extLst>
+              <a:ext uri="{FF2B5EF4-FFF2-40B4-BE49-F238E27FC236}">
+                <a16:creationId xmlns:a16="http://schemas.microsoft.com/office/drawing/2014/main" id="{32210182-771B-1B27-11AE-4E4C6D61D283}"/>
+              </a:ext>
+            </a:extLst>
+          </p:cNvPr>
+          <p:cNvPicPr>
+            <a:picLocks noChangeAspect="1"/>
+          </p:cNvPicPr>
+          <p:nvPr/>
+        </p:nvPicPr>
+        <p:blipFill>
+          <a:blip r:embed="rId11"/>
+          <a:stretch>
+            <a:fillRect/>
+          </a:stretch>
+        </p:blipFill>
+        <p:spPr>
+          <a:xfrm>
+            <a:off x="4809411" y="2288524"/>
+            <a:ext cx="1099558" cy="805770"/>
           </a:xfrm>
           <a:prstGeom prst="rect">
             <a:avLst/>
@@ -4346,7 +5631,12 @@
             <p:ph idx="1"/>
           </p:nvPr>
         </p:nvSpPr>
-        <p:spPr/>
+        <p:spPr>
+          <a:xfrm>
+            <a:off x="838200" y="1528219"/>
+            <a:ext cx="10515600" cy="1463175"/>
+          </a:xfrm>
+        </p:spPr>
         <p:txBody>
           <a:bodyPr/>
           <a:lstStyle/>
@@ -4360,6 +5650,265 @@
             <a:r>
               <a:rPr lang="en-US" dirty="0"/>
               <a:t>What did you think your career would like like when you started, and how has that changed?</a:t>
+            </a:r>
+          </a:p>
+        </p:txBody>
+      </p:sp>
+      <p:sp>
+        <p:nvSpPr>
+          <p:cNvPr id="4" name="Title 1">
+            <a:extLst>
+              <a:ext uri="{FF2B5EF4-FFF2-40B4-BE49-F238E27FC236}">
+                <a16:creationId xmlns:a16="http://schemas.microsoft.com/office/drawing/2014/main" id="{C7BF5672-E089-CB2B-AD95-9C84D202F4EB}"/>
+              </a:ext>
+            </a:extLst>
+          </p:cNvPr>
+          <p:cNvSpPr txBox="1">
+            <a:spLocks/>
+          </p:cNvSpPr>
+          <p:nvPr/>
+        </p:nvSpPr>
+        <p:spPr>
+          <a:xfrm>
+            <a:off x="838200" y="3429000"/>
+            <a:ext cx="10515600" cy="1325563"/>
+          </a:xfrm>
+          <a:prstGeom prst="rect">
+            <a:avLst/>
+          </a:prstGeom>
+        </p:spPr>
+        <p:txBody>
+          <a:bodyPr vert="horz" lIns="91440" tIns="45720" rIns="91440" bIns="45720" rtlCol="0" anchor="ctr">
+            <a:normAutofit/>
+          </a:bodyPr>
+          <a:lstStyle>
+            <a:lvl1pPr algn="l" defTabSz="914400" rtl="0" eaLnBrk="1" latinLnBrk="0" hangingPunct="1">
+              <a:lnSpc>
+                <a:spcPct val="90000"/>
+              </a:lnSpc>
+              <a:spcBef>
+                <a:spcPct val="0"/>
+              </a:spcBef>
+              <a:buNone/>
+              <a:defRPr sz="4400" kern="1200">
+                <a:solidFill>
+                  <a:schemeClr val="tx1"/>
+                </a:solidFill>
+                <a:latin typeface="+mj-lt"/>
+                <a:ea typeface="+mj-ea"/>
+                <a:cs typeface="+mj-cs"/>
+              </a:defRPr>
+            </a:lvl1pPr>
+          </a:lstStyle>
+          <a:p>
+            <a:r>
+              <a:rPr lang="en-US" dirty="0"/>
+              <a:t>Educational journey</a:t>
+            </a:r>
+          </a:p>
+        </p:txBody>
+      </p:sp>
+      <p:sp>
+        <p:nvSpPr>
+          <p:cNvPr id="5" name="Content Placeholder 2">
+            <a:extLst>
+              <a:ext uri="{FF2B5EF4-FFF2-40B4-BE49-F238E27FC236}">
+                <a16:creationId xmlns:a16="http://schemas.microsoft.com/office/drawing/2014/main" id="{1C4CE6D2-6B11-527F-B912-5EB56EBCD5B4}"/>
+              </a:ext>
+            </a:extLst>
+          </p:cNvPr>
+          <p:cNvSpPr txBox="1">
+            <a:spLocks/>
+          </p:cNvSpPr>
+          <p:nvPr/>
+        </p:nvSpPr>
+        <p:spPr>
+          <a:xfrm>
+            <a:off x="838200" y="4529389"/>
+            <a:ext cx="10515600" cy="1463175"/>
+          </a:xfrm>
+          <a:prstGeom prst="rect">
+            <a:avLst/>
+          </a:prstGeom>
+        </p:spPr>
+        <p:txBody>
+          <a:bodyPr vert="horz" lIns="91440" tIns="45720" rIns="91440" bIns="45720" rtlCol="0">
+            <a:normAutofit/>
+          </a:bodyPr>
+          <a:lstStyle>
+            <a:lvl1pPr marL="228600" indent="-228600" algn="l" defTabSz="914400" rtl="0" eaLnBrk="1" latinLnBrk="0" hangingPunct="1">
+              <a:lnSpc>
+                <a:spcPct val="90000"/>
+              </a:lnSpc>
+              <a:spcBef>
+                <a:spcPts val="1000"/>
+              </a:spcBef>
+              <a:buFont typeface="Arial" panose="020B0604020202020204" pitchFamily="34" charset="0"/>
+              <a:buChar char="•"/>
+              <a:defRPr sz="2800" kern="1200">
+                <a:solidFill>
+                  <a:schemeClr val="tx1"/>
+                </a:solidFill>
+                <a:latin typeface="+mn-lt"/>
+                <a:ea typeface="+mn-ea"/>
+                <a:cs typeface="+mn-cs"/>
+              </a:defRPr>
+            </a:lvl1pPr>
+            <a:lvl2pPr marL="685800" indent="-228600" algn="l" defTabSz="914400" rtl="0" eaLnBrk="1" latinLnBrk="0" hangingPunct="1">
+              <a:lnSpc>
+                <a:spcPct val="90000"/>
+              </a:lnSpc>
+              <a:spcBef>
+                <a:spcPts val="500"/>
+              </a:spcBef>
+              <a:buFont typeface="Arial" panose="020B0604020202020204" pitchFamily="34" charset="0"/>
+              <a:buChar char="•"/>
+              <a:defRPr sz="2400" kern="1200">
+                <a:solidFill>
+                  <a:schemeClr val="tx1"/>
+                </a:solidFill>
+                <a:latin typeface="+mn-lt"/>
+                <a:ea typeface="+mn-ea"/>
+                <a:cs typeface="+mn-cs"/>
+              </a:defRPr>
+            </a:lvl2pPr>
+            <a:lvl3pPr marL="1143000" indent="-228600" algn="l" defTabSz="914400" rtl="0" eaLnBrk="1" latinLnBrk="0" hangingPunct="1">
+              <a:lnSpc>
+                <a:spcPct val="90000"/>
+              </a:lnSpc>
+              <a:spcBef>
+                <a:spcPts val="500"/>
+              </a:spcBef>
+              <a:buFont typeface="Arial" panose="020B0604020202020204" pitchFamily="34" charset="0"/>
+              <a:buChar char="•"/>
+              <a:defRPr sz="2000" kern="1200">
+                <a:solidFill>
+                  <a:schemeClr val="tx1"/>
+                </a:solidFill>
+                <a:latin typeface="+mn-lt"/>
+                <a:ea typeface="+mn-ea"/>
+                <a:cs typeface="+mn-cs"/>
+              </a:defRPr>
+            </a:lvl3pPr>
+            <a:lvl4pPr marL="1600200" indent="-228600" algn="l" defTabSz="914400" rtl="0" eaLnBrk="1" latinLnBrk="0" hangingPunct="1">
+              <a:lnSpc>
+                <a:spcPct val="90000"/>
+              </a:lnSpc>
+              <a:spcBef>
+                <a:spcPts val="500"/>
+              </a:spcBef>
+              <a:buFont typeface="Arial" panose="020B0604020202020204" pitchFamily="34" charset="0"/>
+              <a:buChar char="•"/>
+              <a:defRPr sz="1800" kern="1200">
+                <a:solidFill>
+                  <a:schemeClr val="tx1"/>
+                </a:solidFill>
+                <a:latin typeface="+mn-lt"/>
+                <a:ea typeface="+mn-ea"/>
+                <a:cs typeface="+mn-cs"/>
+              </a:defRPr>
+            </a:lvl4pPr>
+            <a:lvl5pPr marL="2057400" indent="-228600" algn="l" defTabSz="914400" rtl="0" eaLnBrk="1" latinLnBrk="0" hangingPunct="1">
+              <a:lnSpc>
+                <a:spcPct val="90000"/>
+              </a:lnSpc>
+              <a:spcBef>
+                <a:spcPts val="500"/>
+              </a:spcBef>
+              <a:buFont typeface="Arial" panose="020B0604020202020204" pitchFamily="34" charset="0"/>
+              <a:buChar char="•"/>
+              <a:defRPr sz="1800" kern="1200">
+                <a:solidFill>
+                  <a:schemeClr val="tx1"/>
+                </a:solidFill>
+                <a:latin typeface="+mn-lt"/>
+                <a:ea typeface="+mn-ea"/>
+                <a:cs typeface="+mn-cs"/>
+              </a:defRPr>
+            </a:lvl5pPr>
+            <a:lvl6pPr marL="2514600" indent="-228600" algn="l" defTabSz="914400" rtl="0" eaLnBrk="1" latinLnBrk="0" hangingPunct="1">
+              <a:lnSpc>
+                <a:spcPct val="90000"/>
+              </a:lnSpc>
+              <a:spcBef>
+                <a:spcPts val="500"/>
+              </a:spcBef>
+              <a:buFont typeface="Arial" panose="020B0604020202020204" pitchFamily="34" charset="0"/>
+              <a:buChar char="•"/>
+              <a:defRPr sz="1800" kern="1200">
+                <a:solidFill>
+                  <a:schemeClr val="tx1"/>
+                </a:solidFill>
+                <a:latin typeface="+mn-lt"/>
+                <a:ea typeface="+mn-ea"/>
+                <a:cs typeface="+mn-cs"/>
+              </a:defRPr>
+            </a:lvl6pPr>
+            <a:lvl7pPr marL="2971800" indent="-228600" algn="l" defTabSz="914400" rtl="0" eaLnBrk="1" latinLnBrk="0" hangingPunct="1">
+              <a:lnSpc>
+                <a:spcPct val="90000"/>
+              </a:lnSpc>
+              <a:spcBef>
+                <a:spcPts val="500"/>
+              </a:spcBef>
+              <a:buFont typeface="Arial" panose="020B0604020202020204" pitchFamily="34" charset="0"/>
+              <a:buChar char="•"/>
+              <a:defRPr sz="1800" kern="1200">
+                <a:solidFill>
+                  <a:schemeClr val="tx1"/>
+                </a:solidFill>
+                <a:latin typeface="+mn-lt"/>
+                <a:ea typeface="+mn-ea"/>
+                <a:cs typeface="+mn-cs"/>
+              </a:defRPr>
+            </a:lvl7pPr>
+            <a:lvl8pPr marL="3429000" indent="-228600" algn="l" defTabSz="914400" rtl="0" eaLnBrk="1" latinLnBrk="0" hangingPunct="1">
+              <a:lnSpc>
+                <a:spcPct val="90000"/>
+              </a:lnSpc>
+              <a:spcBef>
+                <a:spcPts val="500"/>
+              </a:spcBef>
+              <a:buFont typeface="Arial" panose="020B0604020202020204" pitchFamily="34" charset="0"/>
+              <a:buChar char="•"/>
+              <a:defRPr sz="1800" kern="1200">
+                <a:solidFill>
+                  <a:schemeClr val="tx1"/>
+                </a:solidFill>
+                <a:latin typeface="+mn-lt"/>
+                <a:ea typeface="+mn-ea"/>
+                <a:cs typeface="+mn-cs"/>
+              </a:defRPr>
+            </a:lvl8pPr>
+            <a:lvl9pPr marL="3886200" indent="-228600" algn="l" defTabSz="914400" rtl="0" eaLnBrk="1" latinLnBrk="0" hangingPunct="1">
+              <a:lnSpc>
+                <a:spcPct val="90000"/>
+              </a:lnSpc>
+              <a:spcBef>
+                <a:spcPts val="500"/>
+              </a:spcBef>
+              <a:buFont typeface="Arial" panose="020B0604020202020204" pitchFamily="34" charset="0"/>
+              <a:buChar char="•"/>
+              <a:defRPr sz="1800" kern="1200">
+                <a:solidFill>
+                  <a:schemeClr val="tx1"/>
+                </a:solidFill>
+                <a:latin typeface="+mn-lt"/>
+                <a:ea typeface="+mn-ea"/>
+                <a:cs typeface="+mn-cs"/>
+              </a:defRPr>
+            </a:lvl9pPr>
+          </a:lstStyle>
+          <a:p>
+            <a:r>
+              <a:rPr lang="en-US" dirty="0"/>
+              <a:t>Did you ever change majors, research areas, or career goals?</a:t>
+            </a:r>
+          </a:p>
+          <a:p>
+            <a:r>
+              <a:rPr lang="en-US" dirty="0"/>
+              <a:t>What skills from school have been most valuable to your current role?</a:t>
             </a:r>
           </a:p>
         </p:txBody>
@@ -4692,6 +6241,321 @@
 </a:theme>
 </file>
 
+<file path=ppt/theme/theme2.xml><?xml version="1.0" encoding="utf-8"?>
+<a:theme xmlns:a="http://schemas.openxmlformats.org/drawingml/2006/main" name="Office Theme">
+  <a:themeElements>
+    <a:clrScheme name="Office">
+      <a:dk1>
+        <a:sysClr val="windowText" lastClr="000000"/>
+      </a:dk1>
+      <a:lt1>
+        <a:sysClr val="window" lastClr="FFFFFF"/>
+      </a:lt1>
+      <a:dk2>
+        <a:srgbClr val="0E2841"/>
+      </a:dk2>
+      <a:lt2>
+        <a:srgbClr val="E8E8E8"/>
+      </a:lt2>
+      <a:accent1>
+        <a:srgbClr val="156082"/>
+      </a:accent1>
+      <a:accent2>
+        <a:srgbClr val="E97132"/>
+      </a:accent2>
+      <a:accent3>
+        <a:srgbClr val="196B24"/>
+      </a:accent3>
+      <a:accent4>
+        <a:srgbClr val="0F9ED5"/>
+      </a:accent4>
+      <a:accent5>
+        <a:srgbClr val="A02B93"/>
+      </a:accent5>
+      <a:accent6>
+        <a:srgbClr val="4EA72E"/>
+      </a:accent6>
+      <a:hlink>
+        <a:srgbClr val="467886"/>
+      </a:hlink>
+      <a:folHlink>
+        <a:srgbClr val="96607D"/>
+      </a:folHlink>
+    </a:clrScheme>
+    <a:fontScheme name="Office">
+      <a:majorFont>
+        <a:latin typeface="Aptos Display" panose="02110004020202020204"/>
+        <a:ea typeface=""/>
+        <a:cs typeface=""/>
+        <a:font script="Jpan" typeface="游ゴシック Light"/>
+        <a:font script="Hang" typeface="맑은 고딕"/>
+        <a:font script="Hans" typeface="等线 Light"/>
+        <a:font script="Hant" typeface="新細明體"/>
+        <a:font script="Arab" typeface="Times New Roman"/>
+        <a:font script="Hebr" typeface="Times New Roman"/>
+        <a:font script="Thai" typeface="Angsana New"/>
+        <a:font script="Ethi" typeface="Nyala"/>
+        <a:font script="Beng" typeface="Vrinda"/>
+        <a:font script="Gujr" typeface="Shruti"/>
+        <a:font script="Khmr" typeface="MoolBoran"/>
+        <a:font script="Knda" typeface="Tunga"/>
+        <a:font script="Guru" typeface="Raavi"/>
+        <a:font script="Cans" typeface="Euphemia"/>
+        <a:font script="Cher" typeface="Plantagenet Cherokee"/>
+        <a:font script="Yiii" typeface="Microsoft Yi Baiti"/>
+        <a:font script="Tibt" typeface="Microsoft Himalaya"/>
+        <a:font script="Thaa" typeface="MV Boli"/>
+        <a:font script="Deva" typeface="Mangal"/>
+        <a:font script="Telu" typeface="Gautami"/>
+        <a:font script="Taml" typeface="Latha"/>
+        <a:font script="Syrc" typeface="Estrangelo Edessa"/>
+        <a:font script="Orya" typeface="Kalinga"/>
+        <a:font script="Mlym" typeface="Kartika"/>
+        <a:font script="Laoo" typeface="DokChampa"/>
+        <a:font script="Sinh" typeface="Iskoola Pota"/>
+        <a:font script="Mong" typeface="Mongolian Baiti"/>
+        <a:font script="Viet" typeface="Times New Roman"/>
+        <a:font script="Uigh" typeface="Microsoft Uighur"/>
+        <a:font script="Geor" typeface="Sylfaen"/>
+        <a:font script="Armn" typeface="Arial"/>
+        <a:font script="Bugi" typeface="Leelawadee UI"/>
+        <a:font script="Bopo" typeface="Microsoft JhengHei"/>
+        <a:font script="Java" typeface="Javanese Text"/>
+        <a:font script="Lisu" typeface="Segoe UI"/>
+        <a:font script="Mymr" typeface="Myanmar Text"/>
+        <a:font script="Nkoo" typeface="Ebrima"/>
+        <a:font script="Olck" typeface="Nirmala UI"/>
+        <a:font script="Osma" typeface="Ebrima"/>
+        <a:font script="Phag" typeface="Phagspa"/>
+        <a:font script="Syrn" typeface="Estrangelo Edessa"/>
+        <a:font script="Syrj" typeface="Estrangelo Edessa"/>
+        <a:font script="Syre" typeface="Estrangelo Edessa"/>
+        <a:font script="Sora" typeface="Nirmala UI"/>
+        <a:font script="Tale" typeface="Microsoft Tai Le"/>
+        <a:font script="Talu" typeface="Microsoft New Tai Lue"/>
+        <a:font script="Tfng" typeface="Ebrima"/>
+      </a:majorFont>
+      <a:minorFont>
+        <a:latin typeface="Aptos" panose="02110004020202020204"/>
+        <a:ea typeface=""/>
+        <a:cs typeface=""/>
+        <a:font script="Jpan" typeface="游ゴシック"/>
+        <a:font script="Hang" typeface="맑은 고딕"/>
+        <a:font script="Hans" typeface="等线"/>
+        <a:font script="Hant" typeface="新細明體"/>
+        <a:font script="Arab" typeface="Arial"/>
+        <a:font script="Hebr" typeface="Arial"/>
+        <a:font script="Thai" typeface="Cordia New"/>
+        <a:font script="Ethi" typeface="Nyala"/>
+        <a:font script="Beng" typeface="Vrinda"/>
+        <a:font script="Gujr" typeface="Shruti"/>
+        <a:font script="Khmr" typeface="DaunPenh"/>
+        <a:font script="Knda" typeface="Tunga"/>
+        <a:font script="Guru" typeface="Raavi"/>
+        <a:font script="Cans" typeface="Euphemia"/>
+        <a:font script="Cher" typeface="Plantagenet Cherokee"/>
+        <a:font script="Yiii" typeface="Microsoft Yi Baiti"/>
+        <a:font script="Tibt" typeface="Microsoft Himalaya"/>
+        <a:font script="Thaa" typeface="MV Boli"/>
+        <a:font script="Deva" typeface="Mangal"/>
+        <a:font script="Telu" typeface="Gautami"/>
+        <a:font script="Taml" typeface="Latha"/>
+        <a:font script="Syrc" typeface="Estrangelo Edessa"/>
+        <a:font script="Orya" typeface="Kalinga"/>
+        <a:font script="Mlym" typeface="Kartika"/>
+        <a:font script="Laoo" typeface="DokChampa"/>
+        <a:font script="Sinh" typeface="Iskoola Pota"/>
+        <a:font script="Mong" typeface="Mongolian Baiti"/>
+        <a:font script="Viet" typeface="Arial"/>
+        <a:font script="Uigh" typeface="Microsoft Uighur"/>
+        <a:font script="Geor" typeface="Sylfaen"/>
+        <a:font script="Armn" typeface="Arial"/>
+        <a:font script="Bugi" typeface="Leelawadee UI"/>
+        <a:font script="Bopo" typeface="Microsoft JhengHei"/>
+        <a:font script="Java" typeface="Javanese Text"/>
+        <a:font script="Lisu" typeface="Segoe UI"/>
+        <a:font script="Mymr" typeface="Myanmar Text"/>
+        <a:font script="Nkoo" typeface="Ebrima"/>
+        <a:font script="Olck" typeface="Nirmala UI"/>
+        <a:font script="Osma" typeface="Ebrima"/>
+        <a:font script="Phag" typeface="Phagspa"/>
+        <a:font script="Syrn" typeface="Estrangelo Edessa"/>
+        <a:font script="Syrj" typeface="Estrangelo Edessa"/>
+        <a:font script="Syre" typeface="Estrangelo Edessa"/>
+        <a:font script="Sora" typeface="Nirmala UI"/>
+        <a:font script="Tale" typeface="Microsoft Tai Le"/>
+        <a:font script="Talu" typeface="Microsoft New Tai Lue"/>
+        <a:font script="Tfng" typeface="Ebrima"/>
+      </a:minorFont>
+    </a:fontScheme>
+    <a:fmtScheme name="Office">
+      <a:fillStyleLst>
+        <a:solidFill>
+          <a:schemeClr val="phClr"/>
+        </a:solidFill>
+        <a:gradFill rotWithShape="1">
+          <a:gsLst>
+            <a:gs pos="0">
+              <a:schemeClr val="phClr">
+                <a:lumMod val="110000"/>
+                <a:satMod val="105000"/>
+                <a:tint val="67000"/>
+              </a:schemeClr>
+            </a:gs>
+            <a:gs pos="50000">
+              <a:schemeClr val="phClr">
+                <a:lumMod val="105000"/>
+                <a:satMod val="103000"/>
+                <a:tint val="73000"/>
+              </a:schemeClr>
+            </a:gs>
+            <a:gs pos="100000">
+              <a:schemeClr val="phClr">
+                <a:lumMod val="105000"/>
+                <a:satMod val="109000"/>
+                <a:tint val="81000"/>
+              </a:schemeClr>
+            </a:gs>
+          </a:gsLst>
+          <a:lin ang="5400000" scaled="0"/>
+        </a:gradFill>
+        <a:gradFill rotWithShape="1">
+          <a:gsLst>
+            <a:gs pos="0">
+              <a:schemeClr val="phClr">
+                <a:satMod val="103000"/>
+                <a:lumMod val="102000"/>
+                <a:tint val="94000"/>
+              </a:schemeClr>
+            </a:gs>
+            <a:gs pos="50000">
+              <a:schemeClr val="phClr">
+                <a:satMod val="110000"/>
+                <a:lumMod val="100000"/>
+                <a:shade val="100000"/>
+              </a:schemeClr>
+            </a:gs>
+            <a:gs pos="100000">
+              <a:schemeClr val="phClr">
+                <a:lumMod val="99000"/>
+                <a:satMod val="120000"/>
+                <a:shade val="78000"/>
+              </a:schemeClr>
+            </a:gs>
+          </a:gsLst>
+          <a:lin ang="5400000" scaled="0"/>
+        </a:gradFill>
+      </a:fillStyleLst>
+      <a:lnStyleLst>
+        <a:ln w="12700" cap="flat" cmpd="sng" algn="ctr">
+          <a:solidFill>
+            <a:schemeClr val="phClr"/>
+          </a:solidFill>
+          <a:prstDash val="solid"/>
+          <a:miter lim="800000"/>
+        </a:ln>
+        <a:ln w="19050" cap="flat" cmpd="sng" algn="ctr">
+          <a:solidFill>
+            <a:schemeClr val="phClr"/>
+          </a:solidFill>
+          <a:prstDash val="solid"/>
+          <a:miter lim="800000"/>
+        </a:ln>
+        <a:ln w="25400" cap="flat" cmpd="sng" algn="ctr">
+          <a:solidFill>
+            <a:schemeClr val="phClr"/>
+          </a:solidFill>
+          <a:prstDash val="solid"/>
+          <a:miter lim="800000"/>
+        </a:ln>
+      </a:lnStyleLst>
+      <a:effectStyleLst>
+        <a:effectStyle>
+          <a:effectLst/>
+        </a:effectStyle>
+        <a:effectStyle>
+          <a:effectLst/>
+        </a:effectStyle>
+        <a:effectStyle>
+          <a:effectLst>
+            <a:outerShdw blurRad="57150" dist="19050" dir="5400000" algn="ctr" rotWithShape="0">
+              <a:srgbClr val="000000">
+                <a:alpha val="63000"/>
+              </a:srgbClr>
+            </a:outerShdw>
+          </a:effectLst>
+        </a:effectStyle>
+      </a:effectStyleLst>
+      <a:bgFillStyleLst>
+        <a:solidFill>
+          <a:schemeClr val="phClr"/>
+        </a:solidFill>
+        <a:solidFill>
+          <a:schemeClr val="phClr">
+            <a:tint val="95000"/>
+            <a:satMod val="170000"/>
+          </a:schemeClr>
+        </a:solidFill>
+        <a:gradFill rotWithShape="1">
+          <a:gsLst>
+            <a:gs pos="0">
+              <a:schemeClr val="phClr">
+                <a:tint val="93000"/>
+                <a:satMod val="150000"/>
+                <a:shade val="98000"/>
+                <a:lumMod val="102000"/>
+              </a:schemeClr>
+            </a:gs>
+            <a:gs pos="50000">
+              <a:schemeClr val="phClr">
+                <a:tint val="98000"/>
+                <a:satMod val="130000"/>
+                <a:shade val="90000"/>
+                <a:lumMod val="103000"/>
+              </a:schemeClr>
+            </a:gs>
+            <a:gs pos="100000">
+              <a:schemeClr val="phClr">
+                <a:shade val="63000"/>
+                <a:satMod val="120000"/>
+              </a:schemeClr>
+            </a:gs>
+          </a:gsLst>
+          <a:lin ang="5400000" scaled="0"/>
+        </a:gradFill>
+      </a:bgFillStyleLst>
+    </a:fmtScheme>
+  </a:themeElements>
+  <a:objectDefaults>
+    <a:lnDef>
+      <a:spPr/>
+      <a:bodyPr/>
+      <a:lstStyle/>
+      <a:style>
+        <a:lnRef idx="2">
+          <a:schemeClr val="accent1"/>
+        </a:lnRef>
+        <a:fillRef idx="0">
+          <a:schemeClr val="accent1"/>
+        </a:fillRef>
+        <a:effectRef idx="1">
+          <a:schemeClr val="accent1"/>
+        </a:effectRef>
+        <a:fontRef idx="minor">
+          <a:schemeClr val="tx1"/>
+        </a:fontRef>
+      </a:style>
+    </a:lnDef>
+  </a:objectDefaults>
+  <a:extraClrSchemeLst/>
+  <a:extLst>
+    <a:ext uri="{05A4C25C-085E-4340-85A3-A5531E510DB2}">
+      <thm15:themeFamily xmlns:thm15="http://schemas.microsoft.com/office/thememl/2012/main" name="Office Theme" id="{2E142A2C-CD16-42D6-873A-C26D2A0506FA}" vid="{1BDDFF52-6CD6-40A5-AB3C-68EB2F1E4D0A}"/>
+    </a:ext>
+  </a:extLst>
+</a:theme>
+</file>
+
 <file path=docMetadata/LabelInfo.xml><?xml version="1.0" encoding="utf-8"?>
 <clbl:labelList xmlns:clbl="http://schemas.microsoft.com/office/2020/mipLabelMetadata">
   <clbl:label id="{afb58802-ff7a-4bb1-ab21-367ff2ecfc8b}" enabled="0" method="" siteId="{afb58802-ff7a-4bb1-ab21-367ff2ecfc8b}" removed="1"/>

</xml_diff>